<commit_message>
Apply supplied BhuMi logo across site, icons and presentation
</commit_message>
<xml_diff>
--- a/docs/presentation/BhuMi_Pitch_Deck.pptx
+++ b/docs/presentation/BhuMi_Pitch_Deck.pptx
@@ -510,7 +510,7 @@
           <a:lstStyle/>
           <a:p>
             <a:r>
-              <a:t>20 seconds. Introduce BhuMi and the P4 category. We compare the ownership that a documented transaction supports with the mutation that follows. This is a synthetic prototype supporting human review, not an official government service. The wordmark is a temporary original treatment; replace it with the official team logo if supplied.</a:t>
+              <a:t>20 seconds. Introduce BhuMi and the P4 category. We compare the ownership that a documented transaction supports with the mutation that follows. This is a synthetic prototype supporting human review, not an official government service. The logo is supplied by the project owner.</a:t>
             </a:r>
           </a:p>
         </p:txBody>
@@ -4245,138 +4245,33 @@
           </a:p>
         </p:txBody>
       </p:sp>
-      <p:sp>
-        <p:nvSpPr>
-          <p:cNvPr id="6" name="Chevron 5"/>
-          <p:cNvSpPr/>
-          <p:nvPr/>
-        </p:nvSpPr>
-        <p:spPr>
-          <a:xfrm rot="5400000">
+      <p:pic>
+        <p:nvPicPr>
+          <p:cNvPr id="6" name="Picture 5" descr="bhumi-symbol.png"/>
+          <p:cNvPicPr>
+            <a:picLocks noChangeAspect="1"/>
+          </p:cNvPicPr>
+          <p:nvPr/>
+        </p:nvPicPr>
+        <p:blipFill>
+          <a:blip r:embed="rId2"/>
+          <a:stretch>
+            <a:fillRect/>
+          </a:stretch>
+        </p:blipFill>
+        <p:spPr>
+          <a:xfrm>
             <a:off x="685800" y="868680"/>
-            <a:ext cx="320040" cy="164592"/>
-          </a:xfrm>
-          <a:prstGeom prst="chevron">
-            <a:avLst/>
-          </a:prstGeom>
-          <a:solidFill>
-            <a:srgbClr val="8DD5C2"/>
-          </a:solidFill>
-          <a:ln>
-            <a:noFill/>
-          </a:ln>
-        </p:spPr>
-        <p:style>
-          <a:lnRef idx="1">
-            <a:schemeClr val="accent1"/>
-          </a:lnRef>
-          <a:fillRef idx="3">
-            <a:schemeClr val="accent1"/>
-          </a:fillRef>
-          <a:effectRef idx="2">
-            <a:schemeClr val="accent1"/>
-          </a:effectRef>
-          <a:fontRef idx="minor">
-            <a:schemeClr val="lt1"/>
-          </a:fontRef>
-        </p:style>
-        <p:txBody>
-          <a:bodyPr rtlCol="0" anchor="ctr"/>
-          <a:lstStyle/>
-          <a:p>
-            <a:pPr algn="ctr"/>
-          </a:p>
-        </p:txBody>
-      </p:sp>
-      <p:sp>
-        <p:nvSpPr>
-          <p:cNvPr id="7" name="Chevron 6"/>
-          <p:cNvSpPr/>
-          <p:nvPr/>
-        </p:nvSpPr>
-        <p:spPr>
-          <a:xfrm rot="5400000">
-            <a:off x="685800" y="978407"/>
-            <a:ext cx="320040" cy="164592"/>
-          </a:xfrm>
-          <a:prstGeom prst="chevron">
-            <a:avLst/>
-          </a:prstGeom>
-          <a:solidFill>
-            <a:srgbClr val="8DD5C2"/>
-          </a:solidFill>
-          <a:ln>
-            <a:noFill/>
-          </a:ln>
-        </p:spPr>
-        <p:style>
-          <a:lnRef idx="1">
-            <a:schemeClr val="accent1"/>
-          </a:lnRef>
-          <a:fillRef idx="3">
-            <a:schemeClr val="accent1"/>
-          </a:fillRef>
-          <a:effectRef idx="2">
-            <a:schemeClr val="accent1"/>
-          </a:effectRef>
-          <a:fontRef idx="minor">
-            <a:schemeClr val="lt1"/>
-          </a:fontRef>
-        </p:style>
-        <p:txBody>
-          <a:bodyPr rtlCol="0" anchor="ctr"/>
-          <a:lstStyle/>
-          <a:p>
-            <a:pPr algn="ctr"/>
-          </a:p>
-        </p:txBody>
-      </p:sp>
-      <p:sp>
-        <p:nvSpPr>
-          <p:cNvPr id="8" name="Chevron 7"/>
-          <p:cNvSpPr/>
-          <p:nvPr/>
-        </p:nvSpPr>
-        <p:spPr>
-          <a:xfrm rot="5400000">
-            <a:off x="685800" y="1088136"/>
-            <a:ext cx="320040" cy="164592"/>
-          </a:xfrm>
-          <a:prstGeom prst="chevron">
-            <a:avLst/>
-          </a:prstGeom>
-          <a:solidFill>
-            <a:srgbClr val="8DD5C2"/>
-          </a:solidFill>
-          <a:ln>
-            <a:noFill/>
-          </a:ln>
-        </p:spPr>
-        <p:style>
-          <a:lnRef idx="1">
-            <a:schemeClr val="accent1"/>
-          </a:lnRef>
-          <a:fillRef idx="3">
-            <a:schemeClr val="accent1"/>
-          </a:fillRef>
-          <a:effectRef idx="2">
-            <a:schemeClr val="accent1"/>
-          </a:effectRef>
-          <a:fontRef idx="minor">
-            <a:schemeClr val="lt1"/>
-          </a:fontRef>
-        </p:style>
-        <p:txBody>
-          <a:bodyPr rtlCol="0" anchor="ctr"/>
-          <a:lstStyle/>
-          <a:p>
-            <a:pPr algn="ctr"/>
-          </a:p>
-        </p:txBody>
-      </p:sp>
-      <p:sp>
-        <p:nvSpPr>
-          <p:cNvPr id="9" name="TextBox 8"/>
+            <a:ext cx="411480" cy="411480"/>
+          </a:xfrm>
+          <a:prstGeom prst="rect">
+            <a:avLst/>
+          </a:prstGeom>
+        </p:spPr>
+      </p:pic>
+      <p:sp>
+        <p:nvSpPr>
+          <p:cNvPr id="7" name="TextBox 6"/>
           <p:cNvSpPr txBox="1"/>
           <p:nvPr/>
         </p:nvSpPr>
@@ -4415,7 +4310,7 @@
       </p:sp>
       <p:sp>
         <p:nvSpPr>
-          <p:cNvPr id="10" name="Rounded Rectangle 9"/>
+          <p:cNvPr id="8" name="Rounded Rectangle 7"/>
           <p:cNvSpPr/>
           <p:nvPr/>
         </p:nvSpPr>
@@ -4461,7 +4356,7 @@
       </p:sp>
       <p:sp>
         <p:nvSpPr>
-          <p:cNvPr id="11" name="TextBox 10"/>
+          <p:cNvPr id="9" name="TextBox 8"/>
           <p:cNvSpPr txBox="1"/>
           <p:nvPr/>
         </p:nvSpPr>
@@ -4500,7 +4395,7 @@
       </p:sp>
       <p:sp>
         <p:nvSpPr>
-          <p:cNvPr id="12" name="TextBox 11"/>
+          <p:cNvPr id="10" name="TextBox 9"/>
           <p:cNvSpPr txBox="1"/>
           <p:nvPr/>
         </p:nvSpPr>
@@ -4555,7 +4450,7 @@
       </p:sp>
       <p:sp>
         <p:nvSpPr>
-          <p:cNvPr id="13" name="TextBox 12"/>
+          <p:cNvPr id="11" name="TextBox 10"/>
           <p:cNvSpPr txBox="1"/>
           <p:nvPr/>
         </p:nvSpPr>
@@ -4610,7 +4505,7 @@
       </p:sp>
       <p:sp>
         <p:nvSpPr>
-          <p:cNvPr id="14" name="TextBox 13"/>
+          <p:cNvPr id="12" name="TextBox 11"/>
           <p:cNvSpPr txBox="1"/>
           <p:nvPr/>
         </p:nvSpPr>
@@ -4649,7 +4544,7 @@
       </p:sp>
       <p:sp>
         <p:nvSpPr>
-          <p:cNvPr id="15" name="Rounded Rectangle 14"/>
+          <p:cNvPr id="13" name="Rounded Rectangle 12"/>
           <p:cNvSpPr/>
           <p:nvPr/>
         </p:nvSpPr>
@@ -4695,7 +4590,7 @@
       </p:sp>
       <p:sp>
         <p:nvSpPr>
-          <p:cNvPr id="16" name="TextBox 15"/>
+          <p:cNvPr id="14" name="TextBox 13"/>
           <p:cNvSpPr txBox="1"/>
           <p:nvPr/>
         </p:nvSpPr>
@@ -4734,7 +4629,7 @@
       </p:sp>
       <p:sp>
         <p:nvSpPr>
-          <p:cNvPr id="17" name="TextBox 16"/>
+          <p:cNvPr id="15" name="TextBox 14"/>
           <p:cNvSpPr txBox="1"/>
           <p:nvPr/>
         </p:nvSpPr>
@@ -4773,7 +4668,7 @@
       </p:sp>
       <p:sp>
         <p:nvSpPr>
-          <p:cNvPr id="18" name="Rounded Rectangle 17"/>
+          <p:cNvPr id="16" name="Rounded Rectangle 15"/>
           <p:cNvSpPr/>
           <p:nvPr/>
         </p:nvSpPr>
@@ -4819,7 +4714,7 @@
       </p:sp>
       <p:sp>
         <p:nvSpPr>
-          <p:cNvPr id="19" name="TextBox 18"/>
+          <p:cNvPr id="17" name="TextBox 16"/>
           <p:cNvSpPr txBox="1"/>
           <p:nvPr/>
         </p:nvSpPr>
@@ -4858,7 +4753,7 @@
       </p:sp>
       <p:sp>
         <p:nvSpPr>
-          <p:cNvPr id="20" name="TextBox 19"/>
+          <p:cNvPr id="18" name="TextBox 17"/>
           <p:cNvSpPr txBox="1"/>
           <p:nvPr/>
         </p:nvSpPr>
@@ -4897,7 +4792,7 @@
       </p:sp>
       <p:sp>
         <p:nvSpPr>
-          <p:cNvPr id="21" name="Rounded Rectangle 20"/>
+          <p:cNvPr id="19" name="Rounded Rectangle 18"/>
           <p:cNvSpPr/>
           <p:nvPr/>
         </p:nvSpPr>
@@ -4943,7 +4838,7 @@
       </p:sp>
       <p:sp>
         <p:nvSpPr>
-          <p:cNvPr id="22" name="TextBox 21"/>
+          <p:cNvPr id="20" name="TextBox 19"/>
           <p:cNvSpPr txBox="1"/>
           <p:nvPr/>
         </p:nvSpPr>
@@ -4982,7 +4877,7 @@
       </p:sp>
       <p:sp>
         <p:nvSpPr>
-          <p:cNvPr id="23" name="TextBox 22"/>
+          <p:cNvPr id="21" name="TextBox 20"/>
           <p:cNvSpPr txBox="1"/>
           <p:nvPr/>
         </p:nvSpPr>

</xml_diff>